<commit_message>
starting work on solution strategy on powerpoint
also completed solution strategy on report
</commit_message>
<xml_diff>
--- a/presentation.pptx
+++ b/presentation.pptx
@@ -113,6 +113,11 @@
       </a:defRPr>
     </a:lvl9pPr>
   </p:defaultTextStyle>
+  <p:extLst>
+    <p:ext uri="{EFAFB233-063F-42B5-8137-9DF3F51BA10A}">
+      <p15:sldGuideLst xmlns:p15="http://schemas.microsoft.com/office/powerpoint/2012/main"/>
+    </p:ext>
+  </p:extLst>
 </p:presentation>
 </file>
 
@@ -3352,9 +3357,10 @@
           <a:lstStyle/>
           <a:p>
             <a:r>
-              <a:rPr lang="en-US" dirty="0"/>
+              <a:rPr lang="en-US"/>
               <a:t>[title]</a:t>
             </a:r>
+            <a:endParaRPr lang="en-US" dirty="0"/>
           </a:p>
         </p:txBody>
       </p:sp>
@@ -3380,15 +3386,22 @@
           <a:lstStyle/>
           <a:p>
             <a:r>
-              <a:rPr lang="en-US" dirty="0"/>
+              <a:rPr lang="en-US"/>
               <a:t>Benjamin Carey and Jack Smoroske</a:t>
             </a:r>
           </a:p>
           <a:p>
             <a:r>
-              <a:rPr lang="en-US" dirty="0"/>
-              <a:t>CS395, University of Kentucky</a:t>
-            </a:r>
+              <a:rPr lang="en-US"/>
+              <a:t>CS395 Final Project</a:t>
+            </a:r>
+          </a:p>
+          <a:p>
+            <a:r>
+              <a:rPr lang="en-US"/>
+              <a:t>University of Kentucky</a:t>
+            </a:r>
+            <a:endParaRPr lang="en-US" dirty="0"/>
           </a:p>
         </p:txBody>
       </p:sp>
@@ -3726,7 +3739,52 @@
           <a:bodyPr/>
           <a:lstStyle/>
           <a:p>
-            <a:endParaRPr lang="en-US"/>
+            <a:pPr marL="0" indent="0">
+              <a:buNone/>
+            </a:pPr>
+            <a:r>
+              <a:rPr lang="en-US" dirty="0"/>
+              <a:t>How do we identify the correct approach?</a:t>
+            </a:r>
+          </a:p>
+          <a:p>
+            <a:r>
+              <a:rPr lang="en-US" dirty="0"/>
+              <a:t>Checking sums of ranges frequently</a:t>
+            </a:r>
+          </a:p>
+          <a:p>
+            <a:pPr lvl="1"/>
+            <a:r>
+              <a:rPr lang="en-US" dirty="0"/>
+              <a:t>Prefix sums for efficient calculations</a:t>
+            </a:r>
+          </a:p>
+          <a:p>
+            <a:r>
+              <a:rPr lang="en-US" dirty="0"/>
+              <a:t>Consider ranges of messages at a time</a:t>
+            </a:r>
+          </a:p>
+          <a:p>
+            <a:pPr lvl="1"/>
+            <a:r>
+              <a:rPr lang="en-US" dirty="0"/>
+              <a:t>Sliding window reduces time complexity</a:t>
+            </a:r>
+          </a:p>
+          <a:p>
+            <a:r>
+              <a:rPr lang="en-US" dirty="0"/>
+              <a:t>Optimization problem</a:t>
+            </a:r>
+          </a:p>
+          <a:p>
+            <a:pPr lvl="1"/>
+            <a:r>
+              <a:rPr lang="en-US" dirty="0"/>
+              <a:t>Indicates dynamic programming &amp; solving subproblems</a:t>
+            </a:r>
           </a:p>
         </p:txBody>
       </p:sp>

</xml_diff>

<commit_message>
added a name to the problem + finished solution strategy on pptx
</commit_message>
<xml_diff>
--- a/presentation.pptx
+++ b/presentation.pptx
@@ -11,10 +11,11 @@
     <p:sldId id="259" r:id="rId5"/>
     <p:sldId id="260" r:id="rId6"/>
     <p:sldId id="261" r:id="rId7"/>
-    <p:sldId id="262" r:id="rId8"/>
-    <p:sldId id="263" r:id="rId9"/>
-    <p:sldId id="264" r:id="rId10"/>
-    <p:sldId id="265" r:id="rId11"/>
+    <p:sldId id="266" r:id="rId8"/>
+    <p:sldId id="262" r:id="rId9"/>
+    <p:sldId id="263" r:id="rId10"/>
+    <p:sldId id="264" r:id="rId11"/>
+    <p:sldId id="265" r:id="rId12"/>
   </p:sldIdLst>
   <p:sldSz cx="12192000" cy="6858000"/>
   <p:notesSz cx="6858000" cy="9144000"/>
@@ -268,7 +269,7 @@
           <a:p>
             <a:fld id="{293480EE-1A17-4A7E-BC0C-8137FBD0E5B4}" type="datetimeFigureOut">
               <a:rPr lang="en-US" smtClean="0"/>
-              <a:t>5/5/2026</a:t>
+              <a:t>5/6/2026</a:t>
             </a:fld>
             <a:endParaRPr lang="en-US"/>
           </a:p>
@@ -466,7 +467,7 @@
           <a:p>
             <a:fld id="{293480EE-1A17-4A7E-BC0C-8137FBD0E5B4}" type="datetimeFigureOut">
               <a:rPr lang="en-US" smtClean="0"/>
-              <a:t>5/5/2026</a:t>
+              <a:t>5/6/2026</a:t>
             </a:fld>
             <a:endParaRPr lang="en-US"/>
           </a:p>
@@ -674,7 +675,7 @@
           <a:p>
             <a:fld id="{293480EE-1A17-4A7E-BC0C-8137FBD0E5B4}" type="datetimeFigureOut">
               <a:rPr lang="en-US" smtClean="0"/>
-              <a:t>5/5/2026</a:t>
+              <a:t>5/6/2026</a:t>
             </a:fld>
             <a:endParaRPr lang="en-US"/>
           </a:p>
@@ -872,7 +873,7 @@
           <a:p>
             <a:fld id="{293480EE-1A17-4A7E-BC0C-8137FBD0E5B4}" type="datetimeFigureOut">
               <a:rPr lang="en-US" smtClean="0"/>
-              <a:t>5/5/2026</a:t>
+              <a:t>5/6/2026</a:t>
             </a:fld>
             <a:endParaRPr lang="en-US"/>
           </a:p>
@@ -1147,7 +1148,7 @@
           <a:p>
             <a:fld id="{293480EE-1A17-4A7E-BC0C-8137FBD0E5B4}" type="datetimeFigureOut">
               <a:rPr lang="en-US" smtClean="0"/>
-              <a:t>5/5/2026</a:t>
+              <a:t>5/6/2026</a:t>
             </a:fld>
             <a:endParaRPr lang="en-US"/>
           </a:p>
@@ -1412,7 +1413,7 @@
           <a:p>
             <a:fld id="{293480EE-1A17-4A7E-BC0C-8137FBD0E5B4}" type="datetimeFigureOut">
               <a:rPr lang="en-US" smtClean="0"/>
-              <a:t>5/5/2026</a:t>
+              <a:t>5/6/2026</a:t>
             </a:fld>
             <a:endParaRPr lang="en-US"/>
           </a:p>
@@ -1824,7 +1825,7 @@
           <a:p>
             <a:fld id="{293480EE-1A17-4A7E-BC0C-8137FBD0E5B4}" type="datetimeFigureOut">
               <a:rPr lang="en-US" smtClean="0"/>
-              <a:t>5/5/2026</a:t>
+              <a:t>5/6/2026</a:t>
             </a:fld>
             <a:endParaRPr lang="en-US"/>
           </a:p>
@@ -1965,7 +1966,7 @@
           <a:p>
             <a:fld id="{293480EE-1A17-4A7E-BC0C-8137FBD0E5B4}" type="datetimeFigureOut">
               <a:rPr lang="en-US" smtClean="0"/>
-              <a:t>5/5/2026</a:t>
+              <a:t>5/6/2026</a:t>
             </a:fld>
             <a:endParaRPr lang="en-US"/>
           </a:p>
@@ -2078,7 +2079,7 @@
           <a:p>
             <a:fld id="{293480EE-1A17-4A7E-BC0C-8137FBD0E5B4}" type="datetimeFigureOut">
               <a:rPr lang="en-US" smtClean="0"/>
-              <a:t>5/5/2026</a:t>
+              <a:t>5/6/2026</a:t>
             </a:fld>
             <a:endParaRPr lang="en-US"/>
           </a:p>
@@ -2389,7 +2390,7 @@
           <a:p>
             <a:fld id="{293480EE-1A17-4A7E-BC0C-8137FBD0E5B4}" type="datetimeFigureOut">
               <a:rPr lang="en-US" smtClean="0"/>
-              <a:t>5/5/2026</a:t>
+              <a:t>5/6/2026</a:t>
             </a:fld>
             <a:endParaRPr lang="en-US"/>
           </a:p>
@@ -2677,7 +2678,7 @@
           <a:p>
             <a:fld id="{293480EE-1A17-4A7E-BC0C-8137FBD0E5B4}" type="datetimeFigureOut">
               <a:rPr lang="en-US" smtClean="0"/>
-              <a:t>5/5/2026</a:t>
+              <a:t>5/6/2026</a:t>
             </a:fld>
             <a:endParaRPr lang="en-US"/>
           </a:p>
@@ -2918,7 +2919,7 @@
           <a:p>
             <a:fld id="{293480EE-1A17-4A7E-BC0C-8137FBD0E5B4}" type="datetimeFigureOut">
               <a:rPr lang="en-US" smtClean="0"/>
-              <a:t>5/5/2026</a:t>
+              <a:t>5/6/2026</a:t>
             </a:fld>
             <a:endParaRPr lang="en-US"/>
           </a:p>
@@ -3351,16 +3352,29 @@
             <p:ph type="ctrTitle"/>
           </p:nvPr>
         </p:nvSpPr>
-        <p:spPr/>
-        <p:txBody>
-          <a:bodyPr/>
-          <a:lstStyle/>
-          <a:p>
-            <a:r>
-              <a:rPr lang="en-US"/>
-              <a:t>[title]</a:t>
-            </a:r>
-            <a:endParaRPr lang="en-US" dirty="0"/>
+        <p:spPr>
+          <a:xfrm>
+            <a:off x="368215" y="1122363"/>
+            <a:ext cx="11414657" cy="2387600"/>
+          </a:xfrm>
+        </p:spPr>
+        <p:txBody>
+          <a:bodyPr>
+            <a:normAutofit fontScale="90000"/>
+          </a:bodyPr>
+          <a:lstStyle/>
+          <a:p>
+            <a:r>
+              <a:rPr lang="en-US" dirty="0"/>
+              <a:t>“Memory Hungry”:</a:t>
+            </a:r>
+            <a:br>
+              <a:rPr lang="en-US" dirty="0"/>
+            </a:br>
+            <a:r>
+              <a:rPr lang="en-US" dirty="0"/>
+              <a:t>Competitive Programming Techniques</a:t>
+            </a:r>
           </a:p>
         </p:txBody>
       </p:sp>
@@ -3437,6 +3451,138 @@
       </p:grpSpPr>
       <p:sp>
         <p:nvSpPr>
+          <p:cNvPr id="2" name="Title 1">
+            <a:extLst>
+              <a:ext uri="{FF2B5EF4-FFF2-40B4-BE49-F238E27FC236}">
+                <a16:creationId xmlns:a16="http://schemas.microsoft.com/office/drawing/2014/main" id="{DF516864-EE0B-E8D5-37E2-5BE9D589A549}"/>
+              </a:ext>
+            </a:extLst>
+          </p:cNvPr>
+          <p:cNvSpPr>
+            <a:spLocks noGrp="1"/>
+          </p:cNvSpPr>
+          <p:nvPr>
+            <p:ph type="title"/>
+          </p:nvPr>
+        </p:nvSpPr>
+        <p:spPr/>
+        <p:txBody>
+          <a:bodyPr/>
+          <a:lstStyle/>
+          <a:p>
+            <a:r>
+              <a:rPr lang="en-US" dirty="0"/>
+              <a:t>Conclusions</a:t>
+            </a:r>
+          </a:p>
+        </p:txBody>
+      </p:sp>
+      <p:sp>
+        <p:nvSpPr>
+          <p:cNvPr id="3" name="Content Placeholder 2">
+            <a:extLst>
+              <a:ext uri="{FF2B5EF4-FFF2-40B4-BE49-F238E27FC236}">
+                <a16:creationId xmlns:a16="http://schemas.microsoft.com/office/drawing/2014/main" id="{6C484B64-13D3-0C5B-BC46-45B6816B94BA}"/>
+              </a:ext>
+            </a:extLst>
+          </p:cNvPr>
+          <p:cNvSpPr>
+            <a:spLocks noGrp="1"/>
+          </p:cNvSpPr>
+          <p:nvPr>
+            <p:ph idx="1"/>
+          </p:nvPr>
+        </p:nvSpPr>
+        <p:spPr/>
+        <p:txBody>
+          <a:bodyPr/>
+          <a:lstStyle/>
+          <a:p>
+            <a:endParaRPr lang="en-US"/>
+          </a:p>
+        </p:txBody>
+      </p:sp>
+    </p:spTree>
+    <p:extLst>
+      <p:ext uri="{BB962C8B-B14F-4D97-AF65-F5344CB8AC3E}">
+        <p14:creationId xmlns:p14="http://schemas.microsoft.com/office/powerpoint/2010/main" val="525933602"/>
+      </p:ext>
+    </p:extLst>
+  </p:cSld>
+  <p:clrMapOvr>
+    <a:masterClrMapping/>
+  </p:clrMapOvr>
+</p:sld>
+</file>
+
+<file path=ppt/slides/slide11.xml><?xml version="1.0" encoding="utf-8"?>
+<p:sld xmlns:a="http://schemas.openxmlformats.org/drawingml/2006/main" xmlns:r="http://schemas.openxmlformats.org/officeDocument/2006/relationships" xmlns:p="http://schemas.openxmlformats.org/presentationml/2006/main">
+  <p:cSld>
+    <p:spTree>
+      <p:nvGrpSpPr>
+        <p:cNvPr id="1" name=""/>
+        <p:cNvGrpSpPr/>
+        <p:nvPr/>
+      </p:nvGrpSpPr>
+      <p:grpSpPr>
+        <a:xfrm>
+          <a:off x="0" y="0"/>
+          <a:ext cx="0" cy="0"/>
+          <a:chOff x="0" y="0"/>
+          <a:chExt cx="0" cy="0"/>
+        </a:xfrm>
+      </p:grpSpPr>
+      <p:sp>
+        <p:nvSpPr>
+          <p:cNvPr id="2" name="Rectangle 1">
+            <a:extLst>
+              <a:ext uri="{FF2B5EF4-FFF2-40B4-BE49-F238E27FC236}">
+                <a16:creationId xmlns:a16="http://schemas.microsoft.com/office/drawing/2014/main" id="{B61748A4-F7D4-D5EC-5192-C2872BA1E100}"/>
+              </a:ext>
+            </a:extLst>
+          </p:cNvPr>
+          <p:cNvSpPr/>
+          <p:nvPr/>
+        </p:nvSpPr>
+        <p:spPr>
+          <a:xfrm>
+            <a:off x="-103909" y="4464957"/>
+            <a:ext cx="12399818" cy="2337810"/>
+          </a:xfrm>
+          <a:prstGeom prst="rect">
+            <a:avLst/>
+          </a:prstGeom>
+          <a:ln>
+            <a:noFill/>
+          </a:ln>
+        </p:spPr>
+        <p:style>
+          <a:lnRef idx="2">
+            <a:schemeClr val="accent1">
+              <a:shade val="15000"/>
+            </a:schemeClr>
+          </a:lnRef>
+          <a:fillRef idx="1">
+            <a:schemeClr val="accent1"/>
+          </a:fillRef>
+          <a:effectRef idx="0">
+            <a:schemeClr val="accent1"/>
+          </a:effectRef>
+          <a:fontRef idx="minor">
+            <a:schemeClr val="lt1"/>
+          </a:fontRef>
+        </p:style>
+        <p:txBody>
+          <a:bodyPr rtlCol="0" anchor="ctr"/>
+          <a:lstStyle/>
+          <a:p>
+            <a:pPr algn="ctr"/>
+            <a:endParaRPr lang="en-US"/>
+          </a:p>
+        </p:txBody>
+      </p:sp>
+      <p:sp>
+        <p:nvSpPr>
           <p:cNvPr id="4" name="Title 3">
             <a:extLst>
               <a:ext uri="{FF2B5EF4-FFF2-40B4-BE49-F238E27FC236}">
@@ -3451,42 +3597,110 @@
             <p:ph type="title"/>
           </p:nvPr>
         </p:nvSpPr>
+        <p:spPr>
+          <a:xfrm>
+            <a:off x="831850" y="1574724"/>
+            <a:ext cx="10515600" cy="2852737"/>
+          </a:xfrm>
+        </p:spPr>
+        <p:txBody>
+          <a:bodyPr/>
+          <a:lstStyle/>
+          <a:p>
+            <a:r>
+              <a:rPr lang="en-US" b="1" dirty="0"/>
+              <a:t>Questions?</a:t>
+            </a:r>
+          </a:p>
+        </p:txBody>
+      </p:sp>
+      <p:sp>
+        <p:nvSpPr>
+          <p:cNvPr id="5" name="Text Placeholder 4">
+            <a:extLst>
+              <a:ext uri="{FF2B5EF4-FFF2-40B4-BE49-F238E27FC236}">
+                <a16:creationId xmlns:a16="http://schemas.microsoft.com/office/drawing/2014/main" id="{E6D093E9-99D2-75E4-9BD4-968EFA27B837}"/>
+              </a:ext>
+            </a:extLst>
+          </p:cNvPr>
+          <p:cNvSpPr>
+            <a:spLocks noGrp="1"/>
+          </p:cNvSpPr>
+          <p:nvPr>
+            <p:ph type="body" idx="1"/>
+          </p:nvPr>
+        </p:nvSpPr>
         <p:spPr/>
         <p:txBody>
           <a:bodyPr/>
           <a:lstStyle/>
           <a:p>
             <a:r>
-              <a:rPr lang="en-US" dirty="0"/>
-              <a:t>Questions?</a:t>
-            </a:r>
-          </a:p>
-        </p:txBody>
-      </p:sp>
-      <p:sp>
-        <p:nvSpPr>
-          <p:cNvPr id="5" name="Text Placeholder 4">
-            <a:extLst>
-              <a:ext uri="{FF2B5EF4-FFF2-40B4-BE49-F238E27FC236}">
-                <a16:creationId xmlns:a16="http://schemas.microsoft.com/office/drawing/2014/main" id="{E6D093E9-99D2-75E4-9BD4-968EFA27B837}"/>
-              </a:ext>
-            </a:extLst>
-          </p:cNvPr>
-          <p:cNvSpPr>
-            <a:spLocks noGrp="1"/>
-          </p:cNvSpPr>
-          <p:nvPr>
-            <p:ph type="body" idx="1"/>
-          </p:nvPr>
-        </p:nvSpPr>
-        <p:spPr/>
-        <p:txBody>
-          <a:bodyPr/>
-          <a:lstStyle/>
-          <a:p>
-            <a:r>
-              <a:rPr lang="en-US" dirty="0"/>
-              <a:t>Email </a:t>
+              <a:rPr lang="en-US" dirty="0">
+                <a:solidFill>
+                  <a:schemeClr val="bg1"/>
+                </a:solidFill>
+                <a:hlinkClick r:id="rId2">
+                  <a:extLst>
+                    <a:ext uri="{A12FA001-AC4F-418D-AE19-62706E023703}">
+                      <ahyp:hlinkClr xmlns:ahyp="http://schemas.microsoft.com/office/drawing/2018/hyperlinkcolor" val="tx"/>
+                    </a:ext>
+                  </a:extLst>
+                </a:hlinkClick>
+              </a:rPr>
+              <a:t>bjca251@uky.edu</a:t>
+            </a:r>
+            <a:br>
+              <a:rPr lang="en-US" dirty="0">
+                <a:solidFill>
+                  <a:schemeClr val="bg1"/>
+                </a:solidFill>
+              </a:rPr>
+            </a:br>
+            <a:r>
+              <a:rPr lang="en-US" dirty="0">
+                <a:solidFill>
+                  <a:schemeClr val="bg1"/>
+                </a:solidFill>
+                <a:hlinkClick r:id="rId3">
+                  <a:extLst>
+                    <a:ext uri="{A12FA001-AC4F-418D-AE19-62706E023703}">
+                      <ahyp:hlinkClr xmlns:ahyp="http://schemas.microsoft.com/office/drawing/2018/hyperlinkcolor" val="tx"/>
+                    </a:ext>
+                  </a:extLst>
+                </a:hlinkClick>
+              </a:rPr>
+              <a:t>jack.smoroske@uky.edu</a:t>
+            </a:r>
+            <a:br>
+              <a:rPr lang="en-US" dirty="0">
+                <a:solidFill>
+                  <a:schemeClr val="bg1"/>
+                </a:solidFill>
+              </a:rPr>
+            </a:br>
+            <a:r>
+              <a:rPr lang="en-US" dirty="0">
+                <a:solidFill>
+                  <a:schemeClr val="bg1"/>
+                </a:solidFill>
+                <a:hlinkClick r:id="rId4">
+                  <a:extLst>
+                    <a:ext uri="{A12FA001-AC4F-418D-AE19-62706E023703}">
+                      <ahyp:hlinkClr xmlns:ahyp="http://schemas.microsoft.com/office/drawing/2018/hyperlinkcolor" val="tx"/>
+                    </a:ext>
+                  </a:extLst>
+                </a:hlinkClick>
+              </a:rPr>
+              <a:t>jurek@cs.uky.edu</a:t>
+            </a:r>
+            <a:r>
+              <a:rPr lang="en-US" dirty="0">
+                <a:solidFill>
+                  <a:schemeClr val="bg1"/>
+                </a:solidFill>
+              </a:rPr>
+              <a:t> </a:t>
             </a:r>
           </a:p>
         </p:txBody>
@@ -3867,10 +4081,441 @@
           <a:bodyPr/>
           <a:lstStyle/>
           <a:p>
-            <a:endParaRPr lang="en-US"/>
-          </a:p>
-        </p:txBody>
-      </p:sp>
+            <a:pPr marL="0" indent="0">
+              <a:buNone/>
+            </a:pPr>
+            <a:r>
+              <a:rPr lang="en-US" dirty="0"/>
+              <a:t>Prefix sum array is an array where </a:t>
+            </a:r>
+            <a:r>
+              <a:rPr lang="en-US" dirty="0">
+                <a:latin typeface="Consolas" panose="020B0609020204030204" pitchFamily="49" charset="0"/>
+              </a:rPr>
+              <a:t>P[</a:t>
+            </a:r>
+            <a:r>
+              <a:rPr lang="en-US" dirty="0" err="1">
+                <a:latin typeface="Consolas" panose="020B0609020204030204" pitchFamily="49" charset="0"/>
+              </a:rPr>
+              <a:t>i</a:t>
+            </a:r>
+            <a:r>
+              <a:rPr lang="en-US" dirty="0">
+                <a:latin typeface="Consolas" panose="020B0609020204030204" pitchFamily="49" charset="0"/>
+              </a:rPr>
+              <a:t>]=L[1]+L[2]+…+L[</a:t>
+            </a:r>
+            <a:r>
+              <a:rPr lang="en-US" dirty="0" err="1">
+                <a:latin typeface="Consolas" panose="020B0609020204030204" pitchFamily="49" charset="0"/>
+              </a:rPr>
+              <a:t>i</a:t>
+            </a:r>
+            <a:r>
+              <a:rPr lang="en-US" dirty="0">
+                <a:latin typeface="Consolas" panose="020B0609020204030204" pitchFamily="49" charset="0"/>
+              </a:rPr>
+              <a:t>]</a:t>
+            </a:r>
+          </a:p>
+          <a:p>
+            <a:pPr marL="0" indent="0">
+              <a:buNone/>
+            </a:pPr>
+            <a:r>
+              <a:rPr lang="en-US" dirty="0"/>
+              <a:t>Allows for immediate, O(1) indexing when consulting the sums of ranges</a:t>
+            </a:r>
+          </a:p>
+          <a:p>
+            <a:pPr lvl="1"/>
+            <a:r>
+              <a:rPr lang="en-US" dirty="0"/>
+              <a:t>Size of reduced (P[j]/K) or unreduced (P[</a:t>
+            </a:r>
+            <a:r>
+              <a:rPr lang="en-US" dirty="0" err="1"/>
+              <a:t>i</a:t>
+            </a:r>
+            <a:r>
+              <a:rPr lang="en-US" dirty="0"/>
+              <a:t>]-P[j]) sections </a:t>
+            </a:r>
+          </a:p>
+          <a:p>
+            <a:pPr lvl="2"/>
+            <a:r>
+              <a:rPr lang="en-US" dirty="0"/>
+              <a:t>Index j splits in two</a:t>
+            </a:r>
+          </a:p>
+          <a:p>
+            <a:pPr lvl="1"/>
+            <a:r>
+              <a:rPr lang="en-US" dirty="0"/>
+              <a:t>Total cost is 64n + 2P[j]</a:t>
+            </a:r>
+          </a:p>
+          <a:p>
+            <a:pPr lvl="2"/>
+            <a:r>
+              <a:rPr lang="en-US" dirty="0"/>
+              <a:t>Messages 1-j are reduced, regardless of how many n reductions</a:t>
+            </a:r>
+          </a:p>
+        </p:txBody>
+      </p:sp>
+      <p:graphicFrame>
+        <p:nvGraphicFramePr>
+          <p:cNvPr id="5" name="Table 4">
+            <a:extLst>
+              <a:ext uri="{FF2B5EF4-FFF2-40B4-BE49-F238E27FC236}">
+                <a16:creationId xmlns:a16="http://schemas.microsoft.com/office/drawing/2014/main" id="{0FC249A5-A2C6-A418-79D9-1E90317F8B8C}"/>
+              </a:ext>
+            </a:extLst>
+          </p:cNvPr>
+          <p:cNvGraphicFramePr>
+            <a:graphicFrameLocks noGrp="1"/>
+          </p:cNvGraphicFramePr>
+          <p:nvPr>
+            <p:extLst>
+              <p:ext uri="{D42A27DB-BD31-4B8C-83A1-F6EECF244321}">
+                <p14:modId xmlns:p14="http://schemas.microsoft.com/office/powerpoint/2010/main" val="3368506248"/>
+              </p:ext>
+            </p:extLst>
+          </p:nvPr>
+        </p:nvGraphicFramePr>
+        <p:xfrm>
+          <a:off x="2031999" y="5064443"/>
+          <a:ext cx="8128002" cy="1112520"/>
+        </p:xfrm>
+        <a:graphic>
+          <a:graphicData uri="http://schemas.openxmlformats.org/drawingml/2006/table">
+            <a:tbl>
+              <a:tblPr firstRow="1" firstCol="1" bandRow="1">
+                <a:tableStyleId>{5C22544A-7EE6-4342-B048-85BDC9FD1C3A}</a:tableStyleId>
+              </a:tblPr>
+              <a:tblGrid>
+                <a:gridCol w="1354667">
+                  <a:extLst>
+                    <a:ext uri="{9D8B030D-6E8A-4147-A177-3AD203B41FA5}">
+                      <a16:colId xmlns:a16="http://schemas.microsoft.com/office/drawing/2014/main" val="1669290905"/>
+                    </a:ext>
+                  </a:extLst>
+                </a:gridCol>
+                <a:gridCol w="1354667">
+                  <a:extLst>
+                    <a:ext uri="{9D8B030D-6E8A-4147-A177-3AD203B41FA5}">
+                      <a16:colId xmlns:a16="http://schemas.microsoft.com/office/drawing/2014/main" val="267497377"/>
+                    </a:ext>
+                  </a:extLst>
+                </a:gridCol>
+                <a:gridCol w="1354667">
+                  <a:extLst>
+                    <a:ext uri="{9D8B030D-6E8A-4147-A177-3AD203B41FA5}">
+                      <a16:colId xmlns:a16="http://schemas.microsoft.com/office/drawing/2014/main" val="3857196772"/>
+                    </a:ext>
+                  </a:extLst>
+                </a:gridCol>
+                <a:gridCol w="1354667">
+                  <a:extLst>
+                    <a:ext uri="{9D8B030D-6E8A-4147-A177-3AD203B41FA5}">
+                      <a16:colId xmlns:a16="http://schemas.microsoft.com/office/drawing/2014/main" val="1846036229"/>
+                    </a:ext>
+                  </a:extLst>
+                </a:gridCol>
+                <a:gridCol w="1354667">
+                  <a:extLst>
+                    <a:ext uri="{9D8B030D-6E8A-4147-A177-3AD203B41FA5}">
+                      <a16:colId xmlns:a16="http://schemas.microsoft.com/office/drawing/2014/main" val="1777097926"/>
+                    </a:ext>
+                  </a:extLst>
+                </a:gridCol>
+                <a:gridCol w="1354667">
+                  <a:extLst>
+                    <a:ext uri="{9D8B030D-6E8A-4147-A177-3AD203B41FA5}">
+                      <a16:colId xmlns:a16="http://schemas.microsoft.com/office/drawing/2014/main" val="3850076397"/>
+                    </a:ext>
+                  </a:extLst>
+                </a:gridCol>
+              </a:tblGrid>
+              <a:tr h="370840">
+                <a:tc>
+                  <a:txBody>
+                    <a:bodyPr/>
+                    <a:lstStyle/>
+                    <a:p>
+                      <a:r>
+                        <a:rPr lang="en-US" i="1" dirty="0" err="1"/>
+                        <a:t>i</a:t>
+                      </a:r>
+                      <a:endParaRPr lang="en-US" i="1" dirty="0"/>
+                    </a:p>
+                  </a:txBody>
+                  <a:tcPr/>
+                </a:tc>
+                <a:tc>
+                  <a:txBody>
+                    <a:bodyPr/>
+                    <a:lstStyle/>
+                    <a:p>
+                      <a:r>
+                        <a:rPr lang="en-US" dirty="0"/>
+                        <a:t>1</a:t>
+                      </a:r>
+                    </a:p>
+                  </a:txBody>
+                  <a:tcPr/>
+                </a:tc>
+                <a:tc>
+                  <a:txBody>
+                    <a:bodyPr/>
+                    <a:lstStyle/>
+                    <a:p>
+                      <a:r>
+                        <a:rPr lang="en-US" dirty="0"/>
+                        <a:t>2</a:t>
+                      </a:r>
+                    </a:p>
+                  </a:txBody>
+                  <a:tcPr/>
+                </a:tc>
+                <a:tc>
+                  <a:txBody>
+                    <a:bodyPr/>
+                    <a:lstStyle/>
+                    <a:p>
+                      <a:r>
+                        <a:rPr lang="en-US" dirty="0"/>
+                        <a:t>3</a:t>
+                      </a:r>
+                    </a:p>
+                  </a:txBody>
+                  <a:tcPr/>
+                </a:tc>
+                <a:tc>
+                  <a:txBody>
+                    <a:bodyPr/>
+                    <a:lstStyle/>
+                    <a:p>
+                      <a:r>
+                        <a:rPr lang="en-US" dirty="0"/>
+                        <a:t>4</a:t>
+                      </a:r>
+                    </a:p>
+                  </a:txBody>
+                  <a:tcPr/>
+                </a:tc>
+                <a:tc>
+                  <a:txBody>
+                    <a:bodyPr/>
+                    <a:lstStyle/>
+                    <a:p>
+                      <a:r>
+                        <a:rPr lang="en-US" dirty="0"/>
+                        <a:t>5</a:t>
+                      </a:r>
+                    </a:p>
+                  </a:txBody>
+                  <a:tcPr/>
+                </a:tc>
+                <a:extLst>
+                  <a:ext uri="{0D108BD9-81ED-4DB2-BD59-A6C34878D82A}">
+                    <a16:rowId xmlns:a16="http://schemas.microsoft.com/office/drawing/2014/main" val="3515541256"/>
+                  </a:ext>
+                </a:extLst>
+              </a:tr>
+              <a:tr h="370840">
+                <a:tc>
+                  <a:txBody>
+                    <a:bodyPr/>
+                    <a:lstStyle/>
+                    <a:p>
+                      <a:r>
+                        <a:rPr lang="en-US" dirty="0"/>
+                        <a:t>L[</a:t>
+                      </a:r>
+                      <a:r>
+                        <a:rPr lang="en-US" dirty="0" err="1"/>
+                        <a:t>i</a:t>
+                      </a:r>
+                      <a:r>
+                        <a:rPr lang="en-US" dirty="0"/>
+                        <a:t>]</a:t>
+                      </a:r>
+                    </a:p>
+                  </a:txBody>
+                  <a:tcPr/>
+                </a:tc>
+                <a:tc>
+                  <a:txBody>
+                    <a:bodyPr/>
+                    <a:lstStyle/>
+                    <a:p>
+                      <a:r>
+                        <a:rPr lang="en-US" dirty="0"/>
+                        <a:t>10</a:t>
+                      </a:r>
+                    </a:p>
+                  </a:txBody>
+                  <a:tcPr/>
+                </a:tc>
+                <a:tc>
+                  <a:txBody>
+                    <a:bodyPr/>
+                    <a:lstStyle/>
+                    <a:p>
+                      <a:r>
+                        <a:rPr lang="en-US" dirty="0"/>
+                        <a:t>40</a:t>
+                      </a:r>
+                    </a:p>
+                  </a:txBody>
+                  <a:tcPr/>
+                </a:tc>
+                <a:tc>
+                  <a:txBody>
+                    <a:bodyPr/>
+                    <a:lstStyle/>
+                    <a:p>
+                      <a:r>
+                        <a:rPr lang="en-US" dirty="0"/>
+                        <a:t>30</a:t>
+                      </a:r>
+                    </a:p>
+                  </a:txBody>
+                  <a:tcPr/>
+                </a:tc>
+                <a:tc>
+                  <a:txBody>
+                    <a:bodyPr/>
+                    <a:lstStyle/>
+                    <a:p>
+                      <a:r>
+                        <a:rPr lang="en-US" dirty="0"/>
+                        <a:t>60</a:t>
+                      </a:r>
+                    </a:p>
+                  </a:txBody>
+                  <a:tcPr/>
+                </a:tc>
+                <a:tc>
+                  <a:txBody>
+                    <a:bodyPr/>
+                    <a:lstStyle/>
+                    <a:p>
+                      <a:r>
+                        <a:rPr lang="en-US" dirty="0"/>
+                        <a:t>100</a:t>
+                      </a:r>
+                    </a:p>
+                  </a:txBody>
+                  <a:tcPr/>
+                </a:tc>
+                <a:extLst>
+                  <a:ext uri="{0D108BD9-81ED-4DB2-BD59-A6C34878D82A}">
+                    <a16:rowId xmlns:a16="http://schemas.microsoft.com/office/drawing/2014/main" val="3499045040"/>
+                  </a:ext>
+                </a:extLst>
+              </a:tr>
+              <a:tr h="370840">
+                <a:tc>
+                  <a:txBody>
+                    <a:bodyPr/>
+                    <a:lstStyle/>
+                    <a:p>
+                      <a:r>
+                        <a:rPr lang="en-US" dirty="0"/>
+                        <a:t>P[</a:t>
+                      </a:r>
+                      <a:r>
+                        <a:rPr lang="en-US" dirty="0" err="1"/>
+                        <a:t>i</a:t>
+                      </a:r>
+                      <a:r>
+                        <a:rPr lang="en-US" dirty="0"/>
+                        <a:t>]</a:t>
+                      </a:r>
+                    </a:p>
+                  </a:txBody>
+                  <a:tcPr/>
+                </a:tc>
+                <a:tc>
+                  <a:txBody>
+                    <a:bodyPr/>
+                    <a:lstStyle/>
+                    <a:p>
+                      <a:r>
+                        <a:rPr lang="en-US" dirty="0"/>
+                        <a:t>10</a:t>
+                      </a:r>
+                    </a:p>
+                  </a:txBody>
+                  <a:tcPr/>
+                </a:tc>
+                <a:tc>
+                  <a:txBody>
+                    <a:bodyPr/>
+                    <a:lstStyle/>
+                    <a:p>
+                      <a:r>
+                        <a:rPr lang="en-US" dirty="0"/>
+                        <a:t>50</a:t>
+                      </a:r>
+                    </a:p>
+                  </a:txBody>
+                  <a:tcPr/>
+                </a:tc>
+                <a:tc>
+                  <a:txBody>
+                    <a:bodyPr/>
+                    <a:lstStyle/>
+                    <a:p>
+                      <a:r>
+                        <a:rPr lang="en-US" dirty="0"/>
+                        <a:t>80</a:t>
+                      </a:r>
+                    </a:p>
+                  </a:txBody>
+                  <a:tcPr/>
+                </a:tc>
+                <a:tc>
+                  <a:txBody>
+                    <a:bodyPr/>
+                    <a:lstStyle/>
+                    <a:p>
+                      <a:r>
+                        <a:rPr lang="en-US" dirty="0"/>
+                        <a:t>140</a:t>
+                      </a:r>
+                    </a:p>
+                  </a:txBody>
+                  <a:tcPr/>
+                </a:tc>
+                <a:tc>
+                  <a:txBody>
+                    <a:bodyPr/>
+                    <a:lstStyle/>
+                    <a:p>
+                      <a:r>
+                        <a:rPr lang="en-US" dirty="0"/>
+                        <a:t>240</a:t>
+                      </a:r>
+                    </a:p>
+                  </a:txBody>
+                  <a:tcPr/>
+                </a:tc>
+                <a:extLst>
+                  <a:ext uri="{0D108BD9-81ED-4DB2-BD59-A6C34878D82A}">
+                    <a16:rowId xmlns:a16="http://schemas.microsoft.com/office/drawing/2014/main" val="2959153500"/>
+                  </a:ext>
+                </a:extLst>
+              </a:tr>
+            </a:tbl>
+          </a:graphicData>
+        </a:graphic>
+      </p:graphicFrame>
     </p:spTree>
     <p:extLst>
       <p:ext uri="{BB962C8B-B14F-4D97-AF65-F5344CB8AC3E}">
@@ -3950,7 +4595,300 @@
           <a:bodyPr/>
           <a:lstStyle/>
           <a:p>
-            <a:endParaRPr lang="en-US"/>
+            <a:pPr marL="0" indent="0">
+              <a:buNone/>
+            </a:pPr>
+            <a:r>
+              <a:rPr lang="en-US" dirty="0"/>
+              <a:t>Slide a view (L, R) over the array – shift L and R rightward</a:t>
+            </a:r>
+          </a:p>
+          <a:p>
+            <a:pPr lvl="1"/>
+            <a:r>
+              <a:rPr lang="en-US" dirty="0"/>
+              <a:t>Reduces higher complexities to O(n)</a:t>
+            </a:r>
+          </a:p>
+          <a:p>
+            <a:pPr lvl="1"/>
+            <a:endParaRPr lang="en-US" dirty="0"/>
+          </a:p>
+          <a:p>
+            <a:pPr marL="0" indent="0">
+              <a:buNone/>
+            </a:pPr>
+            <a:r>
+              <a:rPr lang="en-US" dirty="0"/>
+              <a:t>Use </a:t>
+            </a:r>
+            <a:r>
+              <a:rPr lang="en-US" dirty="0" err="1"/>
+              <a:t>j_min</a:t>
+            </a:r>
+            <a:r>
+              <a:rPr lang="en-US" dirty="0"/>
+              <a:t> as R for reduced section, L for unreduced</a:t>
+            </a:r>
+          </a:p>
+          <a:p>
+            <a:pPr lvl="1"/>
+            <a:r>
+              <a:rPr lang="en-US" dirty="0"/>
+              <a:t>[1, j_min-1] must be reduced</a:t>
+            </a:r>
+          </a:p>
+          <a:p>
+            <a:pPr lvl="1"/>
+            <a:r>
+              <a:rPr lang="en-US" dirty="0"/>
+              <a:t>[</a:t>
+            </a:r>
+            <a:r>
+              <a:rPr lang="en-US" dirty="0" err="1"/>
+              <a:t>j_min</a:t>
+            </a:r>
+            <a:r>
+              <a:rPr lang="en-US" dirty="0"/>
+              <a:t>, </a:t>
+            </a:r>
+            <a:r>
+              <a:rPr lang="en-US" dirty="0" err="1"/>
+              <a:t>i</a:t>
+            </a:r>
+            <a:r>
+              <a:rPr lang="en-US" dirty="0"/>
+              <a:t>] could be unreduced</a:t>
+            </a:r>
+          </a:p>
+          <a:p>
+            <a:pPr lvl="1"/>
+            <a:r>
+              <a:rPr lang="en-US" dirty="0"/>
+              <a:t>Stay under W</a:t>
+            </a:r>
+          </a:p>
+        </p:txBody>
+      </p:sp>
+      <p:graphicFrame>
+        <p:nvGraphicFramePr>
+          <p:cNvPr id="4" name="Table 3">
+            <a:extLst>
+              <a:ext uri="{FF2B5EF4-FFF2-40B4-BE49-F238E27FC236}">
+                <a16:creationId xmlns:a16="http://schemas.microsoft.com/office/drawing/2014/main" id="{C51B59D3-AB10-CB52-CDF4-9DD10922750C}"/>
+              </a:ext>
+            </a:extLst>
+          </p:cNvPr>
+          <p:cNvGraphicFramePr>
+            <a:graphicFrameLocks noGrp="1"/>
+          </p:cNvGraphicFramePr>
+          <p:nvPr>
+            <p:extLst>
+              <p:ext uri="{D42A27DB-BD31-4B8C-83A1-F6EECF244321}">
+                <p14:modId xmlns:p14="http://schemas.microsoft.com/office/powerpoint/2010/main" val="2490054421"/>
+              </p:ext>
+            </p:extLst>
+          </p:nvPr>
+        </p:nvGraphicFramePr>
+        <p:xfrm>
+          <a:off x="2032000" y="5451226"/>
+          <a:ext cx="8128000" cy="370840"/>
+        </p:xfrm>
+        <a:graphic>
+          <a:graphicData uri="http://schemas.openxmlformats.org/drawingml/2006/table">
+            <a:tbl>
+              <a:tblPr bandRow="1">
+                <a:tableStyleId>{5C22544A-7EE6-4342-B048-85BDC9FD1C3A}</a:tableStyleId>
+              </a:tblPr>
+              <a:tblGrid>
+                <a:gridCol w="1625600">
+                  <a:extLst>
+                    <a:ext uri="{9D8B030D-6E8A-4147-A177-3AD203B41FA5}">
+                      <a16:colId xmlns:a16="http://schemas.microsoft.com/office/drawing/2014/main" val="4139475151"/>
+                    </a:ext>
+                  </a:extLst>
+                </a:gridCol>
+                <a:gridCol w="1625600">
+                  <a:extLst>
+                    <a:ext uri="{9D8B030D-6E8A-4147-A177-3AD203B41FA5}">
+                      <a16:colId xmlns:a16="http://schemas.microsoft.com/office/drawing/2014/main" val="3028617940"/>
+                    </a:ext>
+                  </a:extLst>
+                </a:gridCol>
+                <a:gridCol w="1625600">
+                  <a:extLst>
+                    <a:ext uri="{9D8B030D-6E8A-4147-A177-3AD203B41FA5}">
+                      <a16:colId xmlns:a16="http://schemas.microsoft.com/office/drawing/2014/main" val="2678834873"/>
+                    </a:ext>
+                  </a:extLst>
+                </a:gridCol>
+                <a:gridCol w="1625600">
+                  <a:extLst>
+                    <a:ext uri="{9D8B030D-6E8A-4147-A177-3AD203B41FA5}">
+                      <a16:colId xmlns:a16="http://schemas.microsoft.com/office/drawing/2014/main" val="1593776812"/>
+                    </a:ext>
+                  </a:extLst>
+                </a:gridCol>
+                <a:gridCol w="1625600">
+                  <a:extLst>
+                    <a:ext uri="{9D8B030D-6E8A-4147-A177-3AD203B41FA5}">
+                      <a16:colId xmlns:a16="http://schemas.microsoft.com/office/drawing/2014/main" val="3081511129"/>
+                    </a:ext>
+                  </a:extLst>
+                </a:gridCol>
+              </a:tblGrid>
+              <a:tr h="370840">
+                <a:tc>
+                  <a:txBody>
+                    <a:bodyPr/>
+                    <a:lstStyle/>
+                    <a:p>
+                      <a:r>
+                        <a:rPr lang="en-US" dirty="0"/>
+                        <a:t>50</a:t>
+                      </a:r>
+                    </a:p>
+                  </a:txBody>
+                  <a:tcPr/>
+                </a:tc>
+                <a:tc>
+                  <a:txBody>
+                    <a:bodyPr/>
+                    <a:lstStyle/>
+                    <a:p>
+                      <a:r>
+                        <a:rPr lang="en-US" dirty="0"/>
+                        <a:t>90</a:t>
+                      </a:r>
+                    </a:p>
+                  </a:txBody>
+                  <a:tcPr/>
+                </a:tc>
+                <a:tc>
+                  <a:txBody>
+                    <a:bodyPr/>
+                    <a:lstStyle/>
+                    <a:p>
+                      <a:r>
+                        <a:rPr lang="en-US" dirty="0"/>
+                        <a:t>30</a:t>
+                      </a:r>
+                    </a:p>
+                  </a:txBody>
+                  <a:tcPr/>
+                </a:tc>
+                <a:tc>
+                  <a:txBody>
+                    <a:bodyPr/>
+                    <a:lstStyle/>
+                    <a:p>
+                      <a:r>
+                        <a:rPr lang="en-US" dirty="0"/>
+                        <a:t>20</a:t>
+                      </a:r>
+                    </a:p>
+                  </a:txBody>
+                  <a:tcPr/>
+                </a:tc>
+                <a:tc>
+                  <a:txBody>
+                    <a:bodyPr/>
+                    <a:lstStyle/>
+                    <a:p>
+                      <a:r>
+                        <a:rPr lang="en-US" dirty="0"/>
+                        <a:t>50</a:t>
+                      </a:r>
+                    </a:p>
+                  </a:txBody>
+                  <a:tcPr/>
+                </a:tc>
+                <a:extLst>
+                  <a:ext uri="{0D108BD9-81ED-4DB2-BD59-A6C34878D82A}">
+                    <a16:rowId xmlns:a16="http://schemas.microsoft.com/office/drawing/2014/main" val="184909486"/>
+                  </a:ext>
+                </a:extLst>
+              </a:tr>
+            </a:tbl>
+          </a:graphicData>
+        </a:graphic>
+      </p:graphicFrame>
+      <p:cxnSp>
+        <p:nvCxnSpPr>
+          <p:cNvPr id="6" name="Straight Connector 5">
+            <a:extLst>
+              <a:ext uri="{FF2B5EF4-FFF2-40B4-BE49-F238E27FC236}">
+                <a16:creationId xmlns:a16="http://schemas.microsoft.com/office/drawing/2014/main" id="{23E989B7-E2D9-7143-0D09-9C9ED04AB7EC}"/>
+              </a:ext>
+            </a:extLst>
+          </p:cNvPr>
+          <p:cNvCxnSpPr/>
+          <p:nvPr/>
+        </p:nvCxnSpPr>
+        <p:spPr>
+          <a:xfrm flipV="1">
+            <a:off x="5283882" y="5161144"/>
+            <a:ext cx="0" cy="1015819"/>
+          </a:xfrm>
+          <a:prstGeom prst="line">
+            <a:avLst/>
+          </a:prstGeom>
+        </p:spPr>
+        <p:style>
+          <a:lnRef idx="3">
+            <a:schemeClr val="accent1"/>
+          </a:lnRef>
+          <a:fillRef idx="0">
+            <a:schemeClr val="accent1"/>
+          </a:fillRef>
+          <a:effectRef idx="2">
+            <a:schemeClr val="accent1"/>
+          </a:effectRef>
+          <a:fontRef idx="minor">
+            <a:schemeClr val="tx1"/>
+          </a:fontRef>
+        </p:style>
+      </p:cxnSp>
+      <p:sp>
+        <p:nvSpPr>
+          <p:cNvPr id="7" name="TextBox 6">
+            <a:extLst>
+              <a:ext uri="{FF2B5EF4-FFF2-40B4-BE49-F238E27FC236}">
+                <a16:creationId xmlns:a16="http://schemas.microsoft.com/office/drawing/2014/main" id="{3462D71A-1877-464F-7B3D-EF26311F283A}"/>
+              </a:ext>
+            </a:extLst>
+          </p:cNvPr>
+          <p:cNvSpPr txBox="1"/>
+          <p:nvPr/>
+        </p:nvSpPr>
+        <p:spPr>
+          <a:xfrm>
+            <a:off x="2896622" y="6050779"/>
+            <a:ext cx="3798750" cy="369332"/>
+          </a:xfrm>
+          <a:prstGeom prst="rect">
+            <a:avLst/>
+          </a:prstGeom>
+          <a:noFill/>
+        </p:spPr>
+        <p:txBody>
+          <a:bodyPr wrap="square" rtlCol="0">
+            <a:spAutoFit/>
+          </a:bodyPr>
+          <a:lstStyle/>
+          <a:p>
+            <a:r>
+              <a:rPr lang="en-US" dirty="0"/>
+              <a:t>Ex: W = 150, K = 10		</a:t>
+            </a:r>
+            <a:r>
+              <a:rPr lang="en-US" dirty="0" err="1"/>
+              <a:t>j_min</a:t>
+            </a:r>
+            <a:r>
+              <a:rPr lang="en-US" dirty="0"/>
+              <a:t> = 3</a:t>
+            </a:r>
           </a:p>
         </p:txBody>
       </p:sp>
@@ -3989,7 +4927,7 @@
           <p:cNvPr id="2" name="Title 1">
             <a:extLst>
               <a:ext uri="{FF2B5EF4-FFF2-40B4-BE49-F238E27FC236}">
-                <a16:creationId xmlns:a16="http://schemas.microsoft.com/office/drawing/2014/main" id="{4FE4FDD0-26F6-D2A8-F97D-DC6F9B5ABAF6}"/>
+                <a16:creationId xmlns:a16="http://schemas.microsoft.com/office/drawing/2014/main" id="{3DAD8598-1FF4-8569-59BB-84F8F3B21287}"/>
               </a:ext>
             </a:extLst>
           </p:cNvPr>
@@ -4007,7 +4945,7 @@
           <a:p>
             <a:r>
               <a:rPr lang="en-US" dirty="0"/>
-              <a:t>Dynamic Programming</a:t>
+              <a:t>Sliding Window</a:t>
             </a:r>
           </a:p>
         </p:txBody>
@@ -4017,7 +4955,7 @@
           <p:cNvPr id="3" name="Content Placeholder 2">
             <a:extLst>
               <a:ext uri="{FF2B5EF4-FFF2-40B4-BE49-F238E27FC236}">
-                <a16:creationId xmlns:a16="http://schemas.microsoft.com/office/drawing/2014/main" id="{A14EF197-938F-ABF1-6DC7-59F8FA3213F6}"/>
+                <a16:creationId xmlns:a16="http://schemas.microsoft.com/office/drawing/2014/main" id="{3641F5A6-0B1A-382D-2681-D8DCE145EBCB}"/>
               </a:ext>
             </a:extLst>
           </p:cNvPr>
@@ -4033,14 +4971,93 @@
           <a:bodyPr/>
           <a:lstStyle/>
           <a:p>
-            <a:endParaRPr lang="en-US"/>
+            <a:pPr marL="0" indent="0">
+              <a:buNone/>
+            </a:pPr>
+            <a:r>
+              <a:rPr lang="en-US" dirty="0"/>
+              <a:t>Use </a:t>
+            </a:r>
+            <a:r>
+              <a:rPr lang="en-US" dirty="0" err="1"/>
+              <a:t>j_max</a:t>
+            </a:r>
+            <a:r>
+              <a:rPr lang="en-US" dirty="0"/>
+              <a:t> ( &gt; </a:t>
+            </a:r>
+            <a:r>
+              <a:rPr lang="en-US" dirty="0" err="1"/>
+              <a:t>j_min</a:t>
+            </a:r>
+            <a:r>
+              <a:rPr lang="en-US" dirty="0"/>
+              <a:t>) in a Queue object as another bound</a:t>
+            </a:r>
+          </a:p>
+          <a:p>
+            <a:pPr lvl="1"/>
+            <a:r>
+              <a:rPr lang="en-US" dirty="0"/>
+              <a:t>(</a:t>
+            </a:r>
+            <a:r>
+              <a:rPr lang="en-US" dirty="0" err="1"/>
+              <a:t>j_max</a:t>
+            </a:r>
+            <a:r>
+              <a:rPr lang="en-US" dirty="0"/>
+              <a:t>, </a:t>
+            </a:r>
+            <a:r>
+              <a:rPr lang="en-US" dirty="0" err="1"/>
+              <a:t>i</a:t>
+            </a:r>
+            <a:r>
+              <a:rPr lang="en-US" dirty="0"/>
+              <a:t>) unreduced window, updated discretely</a:t>
+            </a:r>
+          </a:p>
+          <a:p>
+            <a:pPr lvl="1"/>
+            <a:r>
+              <a:rPr lang="en-US" dirty="0"/>
+              <a:t>Push </a:t>
+            </a:r>
+            <a:r>
+              <a:rPr lang="en-US" dirty="0" err="1"/>
+              <a:t>j_max</a:t>
+            </a:r>
+            <a:r>
+              <a:rPr lang="en-US" dirty="0"/>
+              <a:t> right when it falls behind </a:t>
+            </a:r>
+            <a:r>
+              <a:rPr lang="en-US" dirty="0" err="1"/>
+              <a:t>j_min</a:t>
+            </a:r>
+            <a:endParaRPr lang="en-US" dirty="0"/>
+          </a:p>
+          <a:p>
+            <a:pPr lvl="2"/>
+            <a:r>
+              <a:rPr lang="en-US" dirty="0"/>
+              <a:t>Need a new reduction </a:t>
+            </a:r>
+          </a:p>
+          <a:p>
+            <a:pPr lvl="2"/>
+            <a:r>
+              <a:rPr lang="en-US" dirty="0"/>
+              <a:t>Only as far as needed</a:t>
+            </a:r>
           </a:p>
         </p:txBody>
       </p:sp>
     </p:spTree>
     <p:extLst>
       <p:ext uri="{BB962C8B-B14F-4D97-AF65-F5344CB8AC3E}">
-        <p14:creationId xmlns:p14="http://schemas.microsoft.com/office/powerpoint/2010/main" val="220215899"/>
+        <p14:creationId xmlns:p14="http://schemas.microsoft.com/office/powerpoint/2010/main" val="3255189493"/>
       </p:ext>
     </p:extLst>
   </p:cSld>
@@ -4072,7 +5089,7 @@
           <p:cNvPr id="2" name="Title 1">
             <a:extLst>
               <a:ext uri="{FF2B5EF4-FFF2-40B4-BE49-F238E27FC236}">
-                <a16:creationId xmlns:a16="http://schemas.microsoft.com/office/drawing/2014/main" id="{BD1AC060-08BC-45C5-D601-DD3D2F450EC5}"/>
+                <a16:creationId xmlns:a16="http://schemas.microsoft.com/office/drawing/2014/main" id="{4FE4FDD0-26F6-D2A8-F97D-DC6F9B5ABAF6}"/>
               </a:ext>
             </a:extLst>
           </p:cNvPr>
@@ -4090,7 +5107,7 @@
           <a:p>
             <a:r>
               <a:rPr lang="en-US" dirty="0"/>
-              <a:t>Demo</a:t>
+              <a:t>Dynamic Programming</a:t>
             </a:r>
           </a:p>
         </p:txBody>
@@ -4100,7 +5117,7 @@
           <p:cNvPr id="3" name="Content Placeholder 2">
             <a:extLst>
               <a:ext uri="{FF2B5EF4-FFF2-40B4-BE49-F238E27FC236}">
-                <a16:creationId xmlns:a16="http://schemas.microsoft.com/office/drawing/2014/main" id="{3BED3E3F-F817-33C0-F6BF-B91BAC836572}"/>
+                <a16:creationId xmlns:a16="http://schemas.microsoft.com/office/drawing/2014/main" id="{A14EF197-938F-ABF1-6DC7-59F8FA3213F6}"/>
               </a:ext>
             </a:extLst>
           </p:cNvPr>
@@ -4116,14 +5133,432 @@
           <a:bodyPr/>
           <a:lstStyle/>
           <a:p>
-            <a:endParaRPr lang="en-US"/>
-          </a:p>
-        </p:txBody>
-      </p:sp>
+            <a:pPr marL="0" indent="0">
+              <a:buNone/>
+            </a:pPr>
+            <a:r>
+              <a:rPr lang="en-US" dirty="0"/>
+              <a:t>Solve smaller subproblems to build up optimal solution</a:t>
+            </a:r>
+          </a:p>
+          <a:p>
+            <a:pPr lvl="1"/>
+            <a:r>
+              <a:rPr lang="en-US" dirty="0"/>
+              <a:t>“Smart” optimizing vs. greedy</a:t>
+            </a:r>
+          </a:p>
+          <a:p>
+            <a:pPr lvl="1"/>
+            <a:endParaRPr lang="en-US" dirty="0"/>
+          </a:p>
+          <a:p>
+            <a:pPr marL="0" indent="0">
+              <a:buNone/>
+            </a:pPr>
+            <a:r>
+              <a:rPr lang="en-US" dirty="0"/>
+              <a:t>DP table stores how many reductions needed to reduce up to index </a:t>
+            </a:r>
+            <a:r>
+              <a:rPr lang="en-US" dirty="0" err="1"/>
+              <a:t>i</a:t>
+            </a:r>
+            <a:endParaRPr lang="en-US" dirty="0"/>
+          </a:p>
+          <a:p>
+            <a:pPr lvl="1"/>
+            <a:r>
+              <a:rPr lang="en-US" dirty="0"/>
+              <a:t>Increment values inside by 1 whenever new reduction is needed</a:t>
+            </a:r>
+          </a:p>
+          <a:p>
+            <a:pPr lvl="1"/>
+            <a:r>
+              <a:rPr lang="en-US" dirty="0"/>
+              <a:t>Whenever </a:t>
+            </a:r>
+            <a:r>
+              <a:rPr lang="en-US" dirty="0" err="1"/>
+              <a:t>i</a:t>
+            </a:r>
+            <a:r>
+              <a:rPr lang="en-US" dirty="0"/>
+              <a:t>=N, checking </a:t>
+            </a:r>
+            <a:r>
+              <a:rPr lang="en-US" dirty="0" err="1"/>
+              <a:t>dp</a:t>
+            </a:r>
+            <a:r>
+              <a:rPr lang="en-US" dirty="0"/>
+              <a:t>[j] gives us our answer</a:t>
+            </a:r>
+          </a:p>
+          <a:p>
+            <a:pPr lvl="2"/>
+            <a:r>
+              <a:rPr lang="en-US" dirty="0"/>
+              <a:t>j = minimum index of reduced messages to stay under W</a:t>
+            </a:r>
+          </a:p>
+        </p:txBody>
+      </p:sp>
+      <p:graphicFrame>
+        <p:nvGraphicFramePr>
+          <p:cNvPr id="4" name="Table 3">
+            <a:extLst>
+              <a:ext uri="{FF2B5EF4-FFF2-40B4-BE49-F238E27FC236}">
+                <a16:creationId xmlns:a16="http://schemas.microsoft.com/office/drawing/2014/main" id="{ACADB1F2-E6CF-2BE9-51B9-F2CECE9168A4}"/>
+              </a:ext>
+            </a:extLst>
+          </p:cNvPr>
+          <p:cNvGraphicFramePr>
+            <a:graphicFrameLocks noGrp="1"/>
+          </p:cNvGraphicFramePr>
+          <p:nvPr>
+            <p:extLst>
+              <p:ext uri="{D42A27DB-BD31-4B8C-83A1-F6EECF244321}">
+                <p14:modId xmlns:p14="http://schemas.microsoft.com/office/powerpoint/2010/main" val="1358414100"/>
+              </p:ext>
+            </p:extLst>
+          </p:nvPr>
+        </p:nvGraphicFramePr>
+        <p:xfrm>
+          <a:off x="1688332" y="5397881"/>
+          <a:ext cx="8128000" cy="370840"/>
+        </p:xfrm>
+        <a:graphic>
+          <a:graphicData uri="http://schemas.openxmlformats.org/drawingml/2006/table">
+            <a:tbl>
+              <a:tblPr firstCol="1" bandRow="1">
+                <a:tableStyleId>{5C22544A-7EE6-4342-B048-85BDC9FD1C3A}</a:tableStyleId>
+              </a:tblPr>
+              <a:tblGrid>
+                <a:gridCol w="812800">
+                  <a:extLst>
+                    <a:ext uri="{9D8B030D-6E8A-4147-A177-3AD203B41FA5}">
+                      <a16:colId xmlns:a16="http://schemas.microsoft.com/office/drawing/2014/main" val="4214311098"/>
+                    </a:ext>
+                  </a:extLst>
+                </a:gridCol>
+                <a:gridCol w="812800">
+                  <a:extLst>
+                    <a:ext uri="{9D8B030D-6E8A-4147-A177-3AD203B41FA5}">
+                      <a16:colId xmlns:a16="http://schemas.microsoft.com/office/drawing/2014/main" val="3163415228"/>
+                    </a:ext>
+                  </a:extLst>
+                </a:gridCol>
+                <a:gridCol w="812800">
+                  <a:extLst>
+                    <a:ext uri="{9D8B030D-6E8A-4147-A177-3AD203B41FA5}">
+                      <a16:colId xmlns:a16="http://schemas.microsoft.com/office/drawing/2014/main" val="318391170"/>
+                    </a:ext>
+                  </a:extLst>
+                </a:gridCol>
+                <a:gridCol w="812800">
+                  <a:extLst>
+                    <a:ext uri="{9D8B030D-6E8A-4147-A177-3AD203B41FA5}">
+                      <a16:colId xmlns:a16="http://schemas.microsoft.com/office/drawing/2014/main" val="872563897"/>
+                    </a:ext>
+                  </a:extLst>
+                </a:gridCol>
+                <a:gridCol w="812800">
+                  <a:extLst>
+                    <a:ext uri="{9D8B030D-6E8A-4147-A177-3AD203B41FA5}">
+                      <a16:colId xmlns:a16="http://schemas.microsoft.com/office/drawing/2014/main" val="4231043075"/>
+                    </a:ext>
+                  </a:extLst>
+                </a:gridCol>
+                <a:gridCol w="812800">
+                  <a:extLst>
+                    <a:ext uri="{9D8B030D-6E8A-4147-A177-3AD203B41FA5}">
+                      <a16:colId xmlns:a16="http://schemas.microsoft.com/office/drawing/2014/main" val="2815060342"/>
+                    </a:ext>
+                  </a:extLst>
+                </a:gridCol>
+                <a:gridCol w="812800">
+                  <a:extLst>
+                    <a:ext uri="{9D8B030D-6E8A-4147-A177-3AD203B41FA5}">
+                      <a16:colId xmlns:a16="http://schemas.microsoft.com/office/drawing/2014/main" val="1706473021"/>
+                    </a:ext>
+                  </a:extLst>
+                </a:gridCol>
+                <a:gridCol w="812800">
+                  <a:extLst>
+                    <a:ext uri="{9D8B030D-6E8A-4147-A177-3AD203B41FA5}">
+                      <a16:colId xmlns:a16="http://schemas.microsoft.com/office/drawing/2014/main" val="242217426"/>
+                    </a:ext>
+                  </a:extLst>
+                </a:gridCol>
+                <a:gridCol w="812800">
+                  <a:extLst>
+                    <a:ext uri="{9D8B030D-6E8A-4147-A177-3AD203B41FA5}">
+                      <a16:colId xmlns:a16="http://schemas.microsoft.com/office/drawing/2014/main" val="2869219146"/>
+                    </a:ext>
+                  </a:extLst>
+                </a:gridCol>
+                <a:gridCol w="812800">
+                  <a:extLst>
+                    <a:ext uri="{9D8B030D-6E8A-4147-A177-3AD203B41FA5}">
+                      <a16:colId xmlns:a16="http://schemas.microsoft.com/office/drawing/2014/main" val="3474256390"/>
+                    </a:ext>
+                  </a:extLst>
+                </a:gridCol>
+              </a:tblGrid>
+              <a:tr h="370840">
+                <a:tc>
+                  <a:txBody>
+                    <a:bodyPr/>
+                    <a:lstStyle/>
+                    <a:p>
+                      <a:r>
+                        <a:rPr lang="en-US" dirty="0" err="1"/>
+                        <a:t>dp</a:t>
+                      </a:r>
+                      <a:r>
+                        <a:rPr lang="en-US" dirty="0"/>
+                        <a:t>[</a:t>
+                      </a:r>
+                      <a:r>
+                        <a:rPr lang="en-US" dirty="0" err="1"/>
+                        <a:t>i</a:t>
+                      </a:r>
+                      <a:r>
+                        <a:rPr lang="en-US" dirty="0"/>
+                        <a:t>]</a:t>
+                      </a:r>
+                    </a:p>
+                  </a:txBody>
+                  <a:tcPr/>
+                </a:tc>
+                <a:tc>
+                  <a:txBody>
+                    <a:bodyPr/>
+                    <a:lstStyle/>
+                    <a:p>
+                      <a:r>
+                        <a:rPr lang="en-US" dirty="0"/>
+                        <a:t>0</a:t>
+                      </a:r>
+                    </a:p>
+                  </a:txBody>
+                  <a:tcPr/>
+                </a:tc>
+                <a:tc>
+                  <a:txBody>
+                    <a:bodyPr/>
+                    <a:lstStyle/>
+                    <a:p>
+                      <a:r>
+                        <a:rPr lang="en-US" dirty="0"/>
+                        <a:t>1</a:t>
+                      </a:r>
+                    </a:p>
+                  </a:txBody>
+                  <a:tcPr/>
+                </a:tc>
+                <a:tc>
+                  <a:txBody>
+                    <a:bodyPr/>
+                    <a:lstStyle/>
+                    <a:p>
+                      <a:r>
+                        <a:rPr lang="en-US" dirty="0"/>
+                        <a:t>1</a:t>
+                      </a:r>
+                    </a:p>
+                  </a:txBody>
+                  <a:tcPr/>
+                </a:tc>
+                <a:tc>
+                  <a:txBody>
+                    <a:bodyPr/>
+                    <a:lstStyle/>
+                    <a:p>
+                      <a:r>
+                        <a:rPr lang="en-US" dirty="0"/>
+                        <a:t>2</a:t>
+                      </a:r>
+                    </a:p>
+                  </a:txBody>
+                  <a:tcPr/>
+                </a:tc>
+                <a:tc>
+                  <a:txBody>
+                    <a:bodyPr/>
+                    <a:lstStyle/>
+                    <a:p>
+                      <a:r>
+                        <a:rPr lang="en-US" dirty="0"/>
+                        <a:t>2</a:t>
+                      </a:r>
+                    </a:p>
+                  </a:txBody>
+                  <a:tcPr/>
+                </a:tc>
+                <a:tc>
+                  <a:txBody>
+                    <a:bodyPr/>
+                    <a:lstStyle/>
+                    <a:p>
+                      <a:r>
+                        <a:rPr lang="en-US" dirty="0"/>
+                        <a:t>3</a:t>
+                      </a:r>
+                    </a:p>
+                  </a:txBody>
+                  <a:tcPr/>
+                </a:tc>
+                <a:tc>
+                  <a:txBody>
+                    <a:bodyPr/>
+                    <a:lstStyle/>
+                    <a:p>
+                      <a:r>
+                        <a:rPr lang="en-US" dirty="0"/>
+                        <a:t>3</a:t>
+                      </a:r>
+                    </a:p>
+                  </a:txBody>
+                  <a:tcPr/>
+                </a:tc>
+                <a:tc>
+                  <a:txBody>
+                    <a:bodyPr/>
+                    <a:lstStyle/>
+                    <a:p>
+                      <a:r>
+                        <a:rPr lang="en-US" dirty="0"/>
+                        <a:t>4</a:t>
+                      </a:r>
+                    </a:p>
+                  </a:txBody>
+                  <a:tcPr/>
+                </a:tc>
+                <a:tc>
+                  <a:txBody>
+                    <a:bodyPr/>
+                    <a:lstStyle/>
+                    <a:p>
+                      <a:r>
+                        <a:rPr lang="en-US" dirty="0"/>
+                        <a:t>5</a:t>
+                      </a:r>
+                    </a:p>
+                  </a:txBody>
+                  <a:tcPr/>
+                </a:tc>
+                <a:extLst>
+                  <a:ext uri="{0D108BD9-81ED-4DB2-BD59-A6C34878D82A}">
+                    <a16:rowId xmlns:a16="http://schemas.microsoft.com/office/drawing/2014/main" val="1573135696"/>
+                  </a:ext>
+                </a:extLst>
+              </a:tr>
+            </a:tbl>
+          </a:graphicData>
+        </a:graphic>
+      </p:graphicFrame>
+      <p:grpSp>
+        <p:nvGrpSpPr>
+          <p:cNvPr id="9" name="Group 8">
+            <a:extLst>
+              <a:ext uri="{FF2B5EF4-FFF2-40B4-BE49-F238E27FC236}">
+                <a16:creationId xmlns:a16="http://schemas.microsoft.com/office/drawing/2014/main" id="{C897D1F3-F451-BE23-D619-8915C60034C4}"/>
+              </a:ext>
+            </a:extLst>
+          </p:cNvPr>
+          <p:cNvGrpSpPr/>
+          <p:nvPr/>
+        </p:nvGrpSpPr>
+        <p:grpSpPr>
+          <a:xfrm>
+            <a:off x="8487350" y="5868776"/>
+            <a:ext cx="233203" cy="624099"/>
+            <a:chOff x="8303243" y="6069406"/>
+            <a:chExt cx="233203" cy="624099"/>
+          </a:xfrm>
+        </p:grpSpPr>
+        <p:cxnSp>
+          <p:nvCxnSpPr>
+            <p:cNvPr id="6" name="Straight Arrow Connector 5">
+              <a:extLst>
+                <a:ext uri="{FF2B5EF4-FFF2-40B4-BE49-F238E27FC236}">
+                  <a16:creationId xmlns:a16="http://schemas.microsoft.com/office/drawing/2014/main" id="{5666AC2F-3351-3BCE-95F2-C73646394FCA}"/>
+                </a:ext>
+              </a:extLst>
+            </p:cNvPr>
+            <p:cNvCxnSpPr/>
+            <p:nvPr/>
+          </p:nvCxnSpPr>
+          <p:spPr>
+            <a:xfrm flipV="1">
+              <a:off x="8419845" y="6069406"/>
+              <a:ext cx="0" cy="325256"/>
+            </a:xfrm>
+            <a:prstGeom prst="straightConnector1">
+              <a:avLst/>
+            </a:prstGeom>
+            <a:ln>
+              <a:tailEnd type="triangle"/>
+            </a:ln>
+          </p:spPr>
+          <p:style>
+            <a:lnRef idx="1">
+              <a:schemeClr val="accent1"/>
+            </a:lnRef>
+            <a:fillRef idx="0">
+              <a:schemeClr val="accent1"/>
+            </a:fillRef>
+            <a:effectRef idx="0">
+              <a:schemeClr val="accent1"/>
+            </a:effectRef>
+            <a:fontRef idx="minor">
+              <a:schemeClr val="tx1"/>
+            </a:fontRef>
+          </p:style>
+        </p:cxnSp>
+        <p:sp>
+          <p:nvSpPr>
+            <p:cNvPr id="7" name="TextBox 6">
+              <a:extLst>
+                <a:ext uri="{FF2B5EF4-FFF2-40B4-BE49-F238E27FC236}">
+                  <a16:creationId xmlns:a16="http://schemas.microsoft.com/office/drawing/2014/main" id="{9088EB6A-CACF-EB9F-BD5E-C1AA148F21F4}"/>
+                </a:ext>
+              </a:extLst>
+            </p:cNvPr>
+            <p:cNvSpPr txBox="1"/>
+            <p:nvPr/>
+          </p:nvSpPr>
+          <p:spPr>
+            <a:xfrm>
+              <a:off x="8303243" y="6324173"/>
+              <a:ext cx="233203" cy="369332"/>
+            </a:xfrm>
+            <a:prstGeom prst="rect">
+              <a:avLst/>
+            </a:prstGeom>
+            <a:noFill/>
+          </p:spPr>
+          <p:txBody>
+            <a:bodyPr wrap="square" rtlCol="0">
+              <a:spAutoFit/>
+            </a:bodyPr>
+            <a:lstStyle/>
+            <a:p>
+              <a:r>
+                <a:rPr lang="en-US" dirty="0"/>
+                <a:t>j</a:t>
+              </a:r>
+            </a:p>
+          </p:txBody>
+        </p:sp>
+      </p:grpSp>
     </p:spTree>
     <p:extLst>
       <p:ext uri="{BB962C8B-B14F-4D97-AF65-F5344CB8AC3E}">
-        <p14:creationId xmlns:p14="http://schemas.microsoft.com/office/powerpoint/2010/main" val="2076383094"/>
+        <p14:creationId xmlns:p14="http://schemas.microsoft.com/office/powerpoint/2010/main" val="220215899"/>
       </p:ext>
     </p:extLst>
   </p:cSld>
@@ -4155,7 +5590,7 @@
           <p:cNvPr id="2" name="Title 1">
             <a:extLst>
               <a:ext uri="{FF2B5EF4-FFF2-40B4-BE49-F238E27FC236}">
-                <a16:creationId xmlns:a16="http://schemas.microsoft.com/office/drawing/2014/main" id="{DF516864-EE0B-E8D5-37E2-5BE9D589A549}"/>
+                <a16:creationId xmlns:a16="http://schemas.microsoft.com/office/drawing/2014/main" id="{BD1AC060-08BC-45C5-D601-DD3D2F450EC5}"/>
               </a:ext>
             </a:extLst>
           </p:cNvPr>
@@ -4173,7 +5608,7 @@
           <a:p>
             <a:r>
               <a:rPr lang="en-US" dirty="0"/>
-              <a:t>Conclusions</a:t>
+              <a:t>Demo</a:t>
             </a:r>
           </a:p>
         </p:txBody>
@@ -4183,7 +5618,7 @@
           <p:cNvPr id="3" name="Content Placeholder 2">
             <a:extLst>
               <a:ext uri="{FF2B5EF4-FFF2-40B4-BE49-F238E27FC236}">
-                <a16:creationId xmlns:a16="http://schemas.microsoft.com/office/drawing/2014/main" id="{6C484B64-13D3-0C5B-BC46-45B6816B94BA}"/>
+                <a16:creationId xmlns:a16="http://schemas.microsoft.com/office/drawing/2014/main" id="{3BED3E3F-F817-33C0-F6BF-B91BAC836572}"/>
               </a:ext>
             </a:extLst>
           </p:cNvPr>
@@ -4206,7 +5641,7 @@
     </p:spTree>
     <p:extLst>
       <p:ext uri="{BB962C8B-B14F-4D97-AF65-F5344CB8AC3E}">
-        <p14:creationId xmlns:p14="http://schemas.microsoft.com/office/powerpoint/2010/main" val="525933602"/>
+        <p14:creationId xmlns:p14="http://schemas.microsoft.com/office/powerpoint/2010/main" val="2076383094"/>
       </p:ext>
     </p:extLst>
   </p:cSld>

</xml_diff>